<commit_message>
Plain-language rewrite of HTML + PPTX decks (full sentences, explainer line, verified)
</commit_message>
<xml_diff>
--- a/opendesign/mockups/record-race-deck/record-race-deck.pptx
+++ b/opendesign/mockups/record-race-deck/record-race-deck.pptx
@@ -521,7 +521,7 @@
           <a:lstStyle/>
           <a:p>
             <a:r>
-              <a:t>Open with the punchline: two numbers, not one. 24.9 is the best point inside stated guardrails; 20.8 is the number for an experimentalist. Ask the room which they would publish.</a:t>
+              <a:t>Open with the punchline in plain words: two numbers, not one. 24.9 is the best our simulation could build inside fixed rules; 20.8 is the number for real-world dirt. Ask the room which one they would publish.</a:t>
             </a:r>
           </a:p>
         </p:txBody>
@@ -591,7 +591,7 @@
           <a:lstStyle/>
           <a:p>
             <a:r>
-              <a:t>Joint map surprise: both optimum affinities outside surveyed values; efficiency rises through zero hole-side offset. Non-monotonic gap steps map the Ea landscape, not absorption.</a:t>
+              <a:t>The surprise of the campaign: moving layer energy levels changes how hard trapped charges must work to escape, and efficiency climbs even past textbook rules. The winning values are aggressive — stated, not hidden.</a:t>
             </a:r>
           </a:p>
         </p:txBody>
@@ -661,7 +661,7 @@
           <a:lstStyle/>
           <a:p>
             <a:r>
-              <a:t>Four points across four decades on our own cell. Placement of others' numbers would be accusation dressed as analysis.</a:t>
+              <a:t>Four points across four decades of dirt. Placing others here would be an accusation dressed as analysis, so we refuse.</a:t>
             </a:r>
           </a:p>
         </p:txBody>
@@ -731,7 +731,7 @@
           <a:lstStyle/>
           <a:p>
             <a:r>
-              <a:t>Computed from our absorption, not a textbook number. The old Eg/q rule sat above the limit — retired, stated in the paper.</a:t>
+              <a:t>Computed from our absorption, not a textbook. The old rulebook ceiling sat above the physical limit, so we retired it and said so.</a:t>
             </a:r>
           </a:p>
         </p:txBody>
@@ -801,7 +801,7 @@
           <a:lstStyle/>
           <a:p>
             <a:r>
-              <a:t>The answer for an experimentalist. Thickness optimum moves with Nt — invisible to single-variable sweeps. Attainable gaps: 24.44/24.73/24.28%.</a:t>
+              <a:t>The answer for an experimentalist. The best thickness moves with dirt level — invisible to one-variable-at-a-time testing. With realistic resistance: 20.42.</a:t>
             </a:r>
           </a:p>
         </p:txBody>
@@ -871,7 +871,7 @@
           <a:lstStyle/>
           <a:p>
             <a:r>
-              <a:t>Paired test: +2.03 [0.70, 3.51], 6 of 8 trajectories. Routine-defect dose goes flat. Both halves are the finding.</a:t>
+              <a:t>In ultra-clean cells joints win by 2 points; in everyday cells bulk dirt wins and joints go flat. There is no single most-important factor.</a:t>
             </a:r>
           </a:p>
         </p:txBody>
@@ -941,7 +941,7 @@
           <a:lstStyle/>
           <a:p>
             <a:r>
-              <a:t>Six points of FF excess with three named causes, none isolated. Read left to right with the room.</a:t>
+              <a:t>Read left to right with the room: voltage ordinary, current ordinary, squareness of the curve is where simulation exceeds experiment.</a:t>
             </a:r>
           </a:p>
         </p:txBody>
@@ -1011,7 +1011,7 @@
           <a:lstStyle/>
           <a:p>
             <a:r>
-              <a:t>N-sigma degeneracy proved digit-for-digit. The 100 µs floor is 1–2 orders beyond the best films — admitted, not hidden.</a:t>
+              <a:t>Counts alone cannot be compared across studies; we proved the equivalence digit-for-digit. The floor's cleanliness is admitted, not hidden.</a:t>
             </a:r>
           </a:p>
         </p:txBody>
@@ -1081,7 +1081,7 @@
           <a:lstStyle/>
           <a:p>
             <a:r>
-              <a:t>Mistakes published as findings. Both traps gave plausible efficiencies — that is what makes them dangerous.</a:t>
+              <a:t>Plausible-looking efficiencies from pure input errors — that is what makes them dangerous. One-line rule to defeat both.</a:t>
             </a:r>
           </a:p>
         </p:txBody>
@@ -1291,7 +1291,7 @@
           <a:lstStyle/>
           <a:p>
             <a:r>
-              <a:t>The inflation dynamic: 22.02 certified vs 24.17/24.24 simulated. The question is what each number assumes.</a:t>
+              <a:t>Set up the puzzle simply: the computer beats the lab, but only because the computer is allowed to assume a perfect world.</a:t>
             </a:r>
           </a:p>
         </p:txBody>
@@ -1361,7 +1361,7 @@
           <a:lstStyle/>
           <a:p>
             <a:r>
-              <a:t>One sentence to leave the room with. Then the live demo: open the champion def in SCAPS and read 24.95% off the screen.</a:t>
+              <a:t>One sentence to leave the room with. Then the live demo: open the champion file in SCAPS and read the number off the screen.</a:t>
             </a:r>
           </a:p>
         </p:txBody>
@@ -1431,7 +1431,7 @@
           <a:lstStyle/>
           <a:p>
             <a:r>
-              <a:t>Provenance: every def number traces to a printed table. We add only interface blocks and the absorption model, both stated.</a:t>
+              <a:t>Provenance in one sentence: nothing in our files is invented; everything traces to a printed table, and our additions are stated.</a:t>
             </a:r>
           </a:p>
         </p:txBody>
@@ -1501,7 +1501,7 @@
           <a:lstStyle/>
           <a:p>
             <a:r>
-              <a:t>Walk the stack top to bottom. The last row is what matters: deleting it is how inflated numbers are made.</a:t>
+              <a:t>Where two layers meet, electrons get trapped and lost — that is what an interface block models. Deleting this row is how inflated numbers are made.</a:t>
             </a:r>
           </a:p>
         </p:txBody>
@@ -1571,7 +1571,7 @@
           <a:lstStyle/>
           <a:p>
             <a:r>
-              <a:t>Absorption model keeps gap sweeps self-consistent; scripted parasitics block the analytic-derate route.</a:t>
+              <a:t>Each choice closes one cheating route: self-consistent gaps, scripted resistance, visible optics.</a:t>
             </a:r>
           </a:p>
         </p:txBody>
@@ -1641,7 +1641,7 @@
           <a:lstStyle/>
           <a:p>
             <a:r>
-              <a:t>Ghost cells at 27% from a units slip; neutralised interfaces from a set-key slip. Set-then-get verification always.</a:t>
+              <a:t>We publish our mistakes as findings. Both traps gave plausible-looking efficiencies, which is what makes them dangerous.</a:t>
             </a:r>
           </a:p>
         </p:txBody>
@@ -1711,7 +1711,7 @@
           <a:lstStyle/>
           <a:p>
             <a:r>
-              <a:t>Grid, then the joint-affinity surprise, then an optimiser whose box excluded χ 3.7 — a limitation, not a trophy.</a:t>
+              <a:t>Layers of searching: broad grid, then the energy lineup surprise, then a search that could not reach the winner because its box excluded it — stated as a limitation.</a:t>
             </a:r>
           </a:p>
         </p:txBody>
@@ -1781,7 +1781,7 @@
           <a:lstStyle/>
           <a:p>
             <a:r>
-              <a:t>Green climbs slowly — fabrication improving. Orange jumps — assumptions loosening. Our two points straddle the certified record; the gap between them is the argument.</a:t>
+              <a:t>Green climbs slowly because fabrication gets better. Orange jumps because assumptions get looser. Our two ringed points sit on opposite sides of the certified record.</a:t>
             </a:r>
           </a:p>
         </p:txBody>
@@ -1851,7 +1851,7 @@
           <a:lstStyle/>
           <a:p>
             <a:r>
-              <a:t>Read the JV, then the small print: every coordinate is an edge. Best the box allows — which is why it cannot headline alone.</a:t>
+              <a:t>Read the curve, then the small print. Best the box allows is exactly why it cannot headline alone.</a:t>
             </a:r>
           </a:p>
         </p:txBody>
@@ -4896,7 +4896,7 @@
               </a:defRPr>
             </a:pPr>
             <a:r>
-              <a:t>CSPBI3 PEROVSKITES · SIMULATION AUDIT · GROUP SEMINAR</a:t>
+              <a:t>SOLAR CELLS · COMPUTER MODELS · GROUP SEMINAR</a:t>
             </a:r>
           </a:p>
         </p:txBody>
@@ -5014,8 +5014,8 @@
         </p:nvSpPr>
         <p:spPr>
           <a:xfrm>
-            <a:off x="731520" y="4023360"/>
-            <a:ext cx="10698480" cy="1280160"/>
+            <a:off x="731520" y="3840480"/>
+            <a:ext cx="10698480" cy="1828800"/>
           </a:xfrm>
           <a:prstGeom prst="rect">
             <a:avLst/>
@@ -5029,7 +5029,40 @@
           <a:lstStyle/>
           <a:p>
             <a:pPr>
-              <a:defRPr sz="5400">
+              <a:defRPr sz="3000">
+                <a:latin typeface="Georgia"/>
+              </a:defRPr>
+            </a:pPr>
+            <a:r>
+              <a:t>We checked how much of a record solar-cell number is real, and how much comes from optimistic settings.</a:t>
+            </a:r>
+          </a:p>
+        </p:txBody>
+      </p:sp>
+      <p:sp>
+        <p:nvSpPr>
+          <p:cNvPr id="7" name="TextBox 6"/>
+          <p:cNvSpPr txBox="1"/>
+          <p:nvPr/>
+        </p:nvSpPr>
+        <p:spPr>
+          <a:xfrm>
+            <a:off x="731520" y="5120640"/>
+            <a:ext cx="10698480" cy="914400"/>
+          </a:xfrm>
+          <a:prstGeom prst="rect">
+            <a:avLst/>
+          </a:prstGeom>
+          <a:noFill/>
+        </p:spPr>
+        <p:txBody>
+          <a:bodyPr wrap="square">
+            <a:spAutoFit/>
+          </a:bodyPr>
+          <a:lstStyle/>
+          <a:p>
+            <a:pPr>
+              <a:defRPr sz="4400">
                 <a:solidFill>
                   <a:srgbClr val="B3541E"/>
                 </a:solidFill>
@@ -5037,7 +5070,7 @@
               </a:defRPr>
             </a:pPr>
             <a:r>
-              <a:t>24.9% box best  →  20.8% defensible</a:t>
+              <a:t>24.9% best case  →  20.8% honest case</a:t>
             </a:r>
           </a:p>
         </p:txBody>
@@ -5099,7 +5132,7 @@
               </a:defRPr>
             </a:pPr>
             <a:r>
-              <a:t>RESULT · WHY AFFINITIES MOVE IT</a:t>
+              <a:t>RESULT · WHY THE LINEUP MATTERS</a:t>
             </a:r>
           </a:p>
         </p:txBody>
@@ -5135,7 +5168,7 @@
               </a:defRPr>
             </a:pPr>
             <a:r>
-              <a:t>Affinity works through activation energy</a:t>
+              <a:t>Tiny energy shifts decide the efficiency</a:t>
             </a:r>
           </a:p>
         </p:txBody>
@@ -5281,7 +5314,7 @@
               </a:defRPr>
             </a:pPr>
             <a:r>
-              <a:t>RESULT · INTERFACES</a:t>
+              <a:t>RESULT · DIRTY JOINTS</a:t>
             </a:r>
           </a:p>
         </p:txBody>
@@ -5317,7 +5350,7 @@
               </a:defRPr>
             </a:pPr>
             <a:r>
-              <a:t>Interfaces cost four points across the dose</a:t>
+              <a:t>Dirty joints cost four percentage points</a:t>
             </a:r>
           </a:p>
         </p:txBody>
@@ -5413,7 +5446,7 @@
               </a:defRPr>
             </a:pPr>
             <a:r>
-              <a:t>▪  25.11% at 1e8 → 23.84% at the 1e10 guardrail → 21.20% at 1e12</a:t>
+              <a:t>▪  From almost-clean to very dirty joints, our own cell falls from 25.11 to 21.20 percent.</a:t>
             </a:r>
           </a:p>
           <a:p>
@@ -5426,7 +5459,7 @@
               </a:defRPr>
             </a:pPr>
             <a:r>
-              <a:t>▪  Published 24.17 / 24.24 NOT placed here — different stacks, incomplete tables</a:t>
+              <a:t>▪  We do not place other teams' numbers on our curve: their cells differ and their tables are incomplete.</a:t>
             </a:r>
           </a:p>
         </p:txBody>
@@ -5488,7 +5521,7 @@
               </a:defRPr>
             </a:pPr>
             <a:r>
-              <a:t>RESULT · THE SCREEN</a:t>
+              <a:t>RESULT · THE SPEED LIMIT</a:t>
             </a:r>
           </a:p>
         </p:txBody>
@@ -5524,7 +5557,7 @@
               </a:defRPr>
             </a:pPr>
             <a:r>
-              <a:t>A radiative ceiling rules out the no-interface band</a:t>
+              <a:t>Physics sets a voltage ceiling, and our cell obeys it</a:t>
             </a:r>
           </a:p>
         </p:txBody>
@@ -5596,7 +5629,7 @@
               </a:defRPr>
             </a:pPr>
             <a:r>
-              <a:t>▪  Detailed-balance Voc from our own absorption: 1.371 V at 1.65 eV</a:t>
+              <a:t>▪  From our own light-absorption model, no cell of this gap can exceed 1.371 volts.</a:t>
             </a:r>
           </a:p>
           <a:p>
@@ -5609,7 +5642,7 @@
               </a:defRPr>
             </a:pPr>
             <a:r>
-              <a:t>▪  Champion clears it by 0.05 V — every no-interface cell within 0.011 V of it or above</a:t>
+              <a:t>▪  Our champion stops at 1.321 volts. Cells with deleted joints crowd right up against the ceiling.</a:t>
             </a:r>
           </a:p>
           <a:p>
@@ -5622,7 +5655,7 @@
               </a:defRPr>
             </a:pPr>
             <a:r>
-              <a:t>▪  With Krad = 0 nothing pins the splitting: the band has no margin anywhere</a:t>
+              <a:t>▪  A band with no margin anywhere is not evidence of a working cell.</a:t>
             </a:r>
           </a:p>
         </p:txBody>
@@ -5684,7 +5717,7 @@
               </a:defRPr>
             </a:pPr>
             <a:r>
-              <a:t>RESULT · THE DEFENSIBLE NUMBER</a:t>
+              <a:t>RESULT · THE HONEST NUMBER</a:t>
             </a:r>
           </a:p>
         </p:txBody>
@@ -5720,7 +5753,7 @@
               </a:defRPr>
             </a:pPr>
             <a:r>
-              <a:t>Routine defects give 20.82%</a:t>
+              <a:t>A realistically dirty cell gives 20.82 percent</a:t>
             </a:r>
           </a:p>
         </p:txBody>
@@ -5866,7 +5899,7 @@
               </a:defRPr>
             </a:pPr>
             <a:r>
-              <a:t>RESULT · SENSITIVITY</a:t>
+              <a:t>RESULT · WHAT MATTERS MOST</a:t>
             </a:r>
           </a:p>
         </p:txBody>
@@ -5902,7 +5935,7 @@
               </a:defRPr>
             </a:pPr>
             <a:r>
-              <a:t>Interfaces lead at the floor, bulk leads at routine</a:t>
+              <a:t>It depends on how dirty the cell is</a:t>
             </a:r>
           </a:p>
         </p:txBody>
@@ -6048,7 +6081,7 @@
               </a:defRPr>
             </a:pPr>
             <a:r>
-              <a:t>RESULT · AGAINST EXPERIMENT</a:t>
+              <a:t>RESULT · AGAINST THE REAL WORLD</a:t>
             </a:r>
           </a:p>
         </p:txBody>
@@ -6084,7 +6117,7 @@
               </a:defRPr>
             </a:pPr>
             <a:r>
-              <a:t>The excess is fill factor, not voltage</a:t>
+              <a:t>Our extra points come from fill factor, not voltage</a:t>
             </a:r>
           </a:p>
         </p:txBody>
@@ -6180,7 +6213,7 @@
               </a:defRPr>
             </a:pPr>
             <a:r>
-              <a:t>▪  Our Voc is ordinary — records reach 1.27–1.29 V</a:t>
+              <a:t>▪  Our voltage is ordinary — real records already reach 1.27 to 1.29 volts.</a:t>
             </a:r>
           </a:p>
           <a:p>
@@ -6193,7 +6226,7 @@
               </a:defRPr>
             </a:pPr>
             <a:r>
-              <a:t>▪  ~6-pt FF gap unattributed: no TL recombination, no reflector, numerics</a:t>
+              <a:t>▪  The six-point fill-factor gap has three possible causes, and we do not pretend to know which dominates.</a:t>
             </a:r>
           </a:p>
         </p:txBody>
@@ -6255,7 +6288,7 @@
               </a:defRPr>
             </a:pPr>
             <a:r>
-              <a:t>METHOD · PORTABLE METRICS</a:t>
+              <a:t>METHOD · FAIR COMPARISON</a:t>
             </a:r>
           </a:p>
         </p:txBody>
@@ -6291,7 +6324,7 @@
               </a:defRPr>
             </a:pPr>
             <a:r>
-              <a:t>Report lifetimes and velocities, not just densities</a:t>
+              <a:t>Compare lifetimes, not just dirt counts</a:t>
             </a:r>
           </a:p>
         </p:txBody>
@@ -6371,7 +6404,7 @@
                             <a:srgbClr val="FAF7F1"/>
                           </a:solidFill>
                         </a:rPr>
-                        <a:t>Density</a:t>
+                        <a:t>Dirt level</a:t>
                       </a:r>
                     </a:p>
                   </a:txBody>
@@ -6397,7 +6430,7 @@
                             <a:srgbClr val="FAF7F1"/>
                           </a:solidFill>
                         </a:rPr>
-                        <a:t>τ / S</a:t>
+                        <a:t>Lifetime / surface speed</a:t>
                       </a:r>
                     </a:p>
                   </a:txBody>
@@ -6420,7 +6453,7 @@
                         </a:defRPr>
                       </a:pPr>
                       <a:r>
-                        <a:t>Nt 1e12 (floor)</a:t>
+                        <a:t>Cleanest allowed</a:t>
                       </a:r>
                     </a:p>
                   </a:txBody>
@@ -6437,7 +6470,7 @@
                         </a:defRPr>
                       </a:pPr>
                       <a:r>
-                        <a:t>τ = 100 µs</a:t>
+                        <a:t>charges live 100 microseconds</a:t>
                       </a:r>
                     </a:p>
                   </a:txBody>
@@ -6456,7 +6489,7 @@
                         </a:defRPr>
                       </a:pPr>
                       <a:r>
-                        <a:t>Nt 1e15 (routine)</a:t>
+                        <a:t>Everyday dirt</a:t>
                       </a:r>
                     </a:p>
                   </a:txBody>
@@ -6473,7 +6506,7 @@
                         </a:defRPr>
                       </a:pPr>
                       <a:r>
-                        <a:t>τ = 0.1 µs</a:t>
+                        <a:t>charges live 0.1 microseconds</a:t>
                       </a:r>
                     </a:p>
                   </a:txBody>
@@ -6492,7 +6525,7 @@
                         </a:defRPr>
                       </a:pPr>
                       <a:r>
-                        <a:t>Nif 1e10 (guardrail)</a:t>
+                        <a:t>Joint floor</a:t>
                       </a:r>
                     </a:p>
                   </a:txBody>
@@ -6509,7 +6542,7 @@
                         </a:defRPr>
                       </a:pPr>
                       <a:r>
-                        <a:t>S = 100 cm/s</a:t>
+                        <a:t>surface speed 100 cm/s</a:t>
                       </a:r>
                     </a:p>
                   </a:txBody>
@@ -6551,7 +6584,20 @@
               </a:defRPr>
             </a:pPr>
             <a:r>
-              <a:t>▪  N and σ enter only as their product — τ and S are cross-study currency</a:t>
+              <a:t>▪  Dirt count times trap size is what physics actually sees.</a:t>
+            </a:r>
+          </a:p>
+          <a:p>
+            <a:pPr>
+              <a:spcAft>
+                <a:spcPts val="1400"/>
+              </a:spcAft>
+              <a:defRPr sz="2000">
+                <a:latin typeface="Georgia"/>
+              </a:defRPr>
+            </a:pPr>
+            <a:r>
+              <a:t>▪  Lifetimes and surface speeds let studies compare fairly — and our 100-microsecond floor is far cleaner than the best real films.</a:t>
             </a:r>
           </a:p>
         </p:txBody>
@@ -6613,7 +6659,7 @@
               </a:defRPr>
             </a:pPr>
             <a:r>
-              <a:t>HONESTY · SCRIPTING</a:t>
+              <a:t>HONESTY · SOFTWARE TRAPS</a:t>
             </a:r>
           </a:p>
         </p:txBody>
@@ -6649,7 +6695,7 @@
               </a:defRPr>
             </a:pPr>
             <a:r>
-              <a:t>Two scripting traps that fabricate cells</a:t>
+              <a:t>Two software traps that invent fake cells</a:t>
             </a:r>
           </a:p>
         </p:txBody>
@@ -6721,7 +6767,7 @@
               </a:defRPr>
             </a:pPr>
             <a:r>
-              <a:t>▪  Units trap: SI-valued set inputs overdose 10⁶× — ghost cells up to 27%</a:t>
+              <a:t>▪  Mixing metric and practical units overdoses the cell a million-fold and invents ghost cells near 27 percent.</a:t>
             </a:r>
           </a:p>
           <a:p>
@@ -6734,7 +6780,7 @@
               </a:defRPr>
             </a:pPr>
             <a:r>
-              <a:t>▪  σ trap: the capture cross-section set-key neutralises interfaces</a:t>
+              <a:t>▪  One trap-size command silently switches the traps off instead of resizing them.</a:t>
             </a:r>
           </a:p>
           <a:p>
@@ -6747,7 +6793,7 @@
               </a:defRPr>
             </a:pPr>
             <a:r>
-              <a:t>▪  Rule: definition files for structure, set-then-get verification always</a:t>
+              <a:t>▪  Rule: build structure in files, and always read every scripted value back before believing a run.</a:t>
             </a:r>
           </a:p>
         </p:txBody>
@@ -6809,7 +6855,7 @@
               </a:defRPr>
             </a:pPr>
             <a:r>
-              <a:t>CONTRIBUTION · STANDARD</a:t>
+              <a:t>CONTRIBUTION · A STANDARD</a:t>
             </a:r>
           </a:p>
         </p:txBody>
@@ -6845,7 +6891,7 @@
               </a:defRPr>
             </a:pPr>
             <a:r>
-              <a:t>A checklist for comparable SCAPS claims</a:t>
+              <a:t>A checklist so future studies can be compared</a:t>
             </a:r>
           </a:p>
         </p:txBody>
@@ -6917,7 +6963,7 @@
               </a:defRPr>
             </a:pPr>
             <a:r>
-              <a:t>▪  Interface status + Nif + σ (or S) · bulk Nt + σ (or τ)</a:t>
+              <a:t>▪  State joint dirt plus trap size — or the lifetime and surface speed.</a:t>
             </a:r>
           </a:p>
           <a:p>
@@ -6930,7 +6976,7 @@
               </a:defRPr>
             </a:pPr>
             <a:r>
-              <a:t>▪  Unit-system declaration · Rs basis, computed not assumed</a:t>
+              <a:t>▪  State which unit system every number uses, and the resistance basis.</a:t>
             </a:r>
           </a:p>
           <a:p>
@@ -6943,7 +6989,7 @@
               </a:defRPr>
             </a:pPr>
             <a:r>
-              <a:t>▪  Both contact work functions · surveyed vs adopted affinities</a:t>
+              <a:t>▪  State both contact energy levels, and which affinities were surveyed versus adopted.</a:t>
             </a:r>
           </a:p>
           <a:p>
@@ -6956,7 +7002,7 @@
               </a:defRPr>
             </a:pPr>
             <a:r>
-              <a:t>▪  Model-derived radiative screen · archived receipts</a:t>
+              <a:t>▪  State the radiative ceiling used, and archive every input file.</a:t>
             </a:r>
           </a:p>
         </p:txBody>
@@ -7054,7 +7100,7 @@
               </a:defRPr>
             </a:pPr>
             <a:r>
-              <a:t>What this work cannot say</a:t>
+              <a:t>What this work cannot tell you</a:t>
             </a:r>
           </a:p>
         </p:txBody>
@@ -7126,7 +7172,7 @@
               </a:defRPr>
             </a:pPr>
             <a:r>
-              <a:t>▪  No optimiser brackets the champion — best-of-evaluated, not proven optimal</a:t>
+              <a:t>▪  No search method proves our best cell is the global best — it is the best we evaluated.</a:t>
             </a:r>
           </a:p>
           <a:p>
@@ -7139,7 +7185,7 @@
               </a:defRPr>
             </a:pPr>
             <a:r>
-              <a:t>▪  No phase stability, ion migration, or damp-heat — SCAPS steady state only</a:t>
+              <a:t>▪  We model steady electricity only: no aging, no moisture damage, no crystal decay.</a:t>
             </a:r>
           </a:p>
           <a:p>
@@ -7152,7 +7198,7 @@
               </a:defRPr>
             </a:pPr>
             <a:r>
-              <a:t>▪  No experimental calibration — the loss budget compares, it does not fit</a:t>
+              <a:t>▪  We never fitted the model to a real measured cell, so the comparison table compares rather than calibrates.</a:t>
             </a:r>
           </a:p>
         </p:txBody>
@@ -7250,7 +7296,7 @@
               </a:defRPr>
             </a:pPr>
             <a:r>
-              <a:t>Simulation records keep climbing past experiment</a:t>
+              <a:t>Computer models now beat the best real solar cells — on paper</a:t>
             </a:r>
           </a:p>
         </p:txBody>
@@ -7322,7 +7368,7 @@
               </a:defRPr>
             </a:pPr>
             <a:r>
-              <a:t>▪  Certified CsPbI3 record: 22.02% — simulation claims reach 24.2% and beyond</a:t>
+              <a:t>▪  The best certified cesium-lead-iodide cell turns 22.02 percent of sunlight into electricity.</a:t>
             </a:r>
           </a:p>
           <a:p>
@@ -7335,7 +7381,7 @@
               </a:defRPr>
             </a:pPr>
             <a:r>
-              <a:t>▪  Highest numbers come with interfaces removed or unreachable defect densities</a:t>
+              <a:t>▪  Computer simulations of similar cells claim over 24 percent.</a:t>
             </a:r>
           </a:p>
           <a:p>
@@ -7348,7 +7394,7 @@
               </a:defRPr>
             </a:pPr>
             <a:r>
-              <a:t>▪  Raw inputs routinely withheld — nobody can re-run anyone else</a:t>
+              <a:t>▪  The gap is not fraud. It is hidden assumptions: missing dirt, perfect contacts, ideal materials.</a:t>
             </a:r>
           </a:p>
         </p:txBody>
@@ -7446,7 +7492,7 @@
               </a:defRPr>
             </a:pPr>
             <a:r>
-              <a:t>Claim 20.8. Cite 24.9 as a bound.</a:t>
+              <a:t>Claim 20.8. Cite 24.9 as a limit.</a:t>
             </a:r>
           </a:p>
         </p:txBody>
@@ -7518,7 +7564,7 @@
               </a:defRPr>
             </a:pPr>
             <a:r>
-              <a:t>▪  Every number archived · every assumption priced · scripts regenerate every receipt</a:t>
+              <a:t>▪  Every number archived, every assumption priced, every receipt regenerable from scripts.</a:t>
             </a:r>
           </a:p>
           <a:p>
@@ -7593,7 +7639,7 @@
               </a:defRPr>
             </a:pPr>
             <a:r>
-              <a:t>WHERE THE NUMBERS COME FROM</a:t>
+              <a:t>WHERE OUR SETTINGS COME FROM</a:t>
             </a:r>
           </a:p>
         </p:txBody>
@@ -7629,7 +7675,7 @@
               </a:defRPr>
             </a:pPr>
             <a:r>
-              <a:t>Our parameters come from the Hossain programme</a:t>
+              <a:t>Every setting we used comes from a published table</a:t>
             </a:r>
           </a:p>
         </p:txBody>
@@ -7711,7 +7757,7 @@
                             <a:srgbClr val="FAF7F1"/>
                           </a:solidFill>
                         </a:rPr>
-                        <a:t>Device</a:t>
+                        <a:t>Cell</a:t>
                       </a:r>
                     </a:p>
                   </a:txBody>
@@ -7737,7 +7783,7 @@
                             <a:srgbClr val="FAF7F1"/>
                           </a:solidFill>
                         </a:rPr>
-                        <a:t>Voc</a:t>
+                        <a:t>Voltage</a:t>
                       </a:r>
                     </a:p>
                   </a:txBody>
@@ -7763,7 +7809,7 @@
                             <a:srgbClr val="FAF7F1"/>
                           </a:solidFill>
                         </a:rPr>
-                        <a:t>Jsc</a:t>
+                        <a:t>Current</a:t>
                       </a:r>
                     </a:p>
                   </a:txBody>
@@ -7789,7 +7835,7 @@
                             <a:srgbClr val="FAF7F1"/>
                           </a:solidFill>
                         </a:rPr>
-                        <a:t>FF</a:t>
+                        <a:t>Fill factor</a:t>
                       </a:r>
                     </a:p>
                   </a:txBody>
@@ -7812,7 +7858,7 @@
                         </a:defRPr>
                       </a:pPr>
                       <a:r>
-                        <a:t>Hossain 2022 printed (17.90%)</a:t>
+                        <a:t>Hossain 2022, printed (17.90%)</a:t>
                       </a:r>
                     </a:p>
                   </a:txBody>
@@ -7882,7 +7928,7 @@
                         </a:defRPr>
                       </a:pPr>
                       <a:r>
-                        <a:t>Our baseline (18.99%)</a:t>
+                        <a:t>Our rebuild (18.99%)</a:t>
                       </a:r>
                     </a:p>
                   </a:txBody>
@@ -7975,7 +8021,7 @@
               </a:defRPr>
             </a:pPr>
             <a:r>
-              <a:t>▪  2022: 96 transport-layer combos screened, TiO2/CBTS wins</a:t>
+              <a:t>▪  In 2022, the Hossain team tested 96 layer combinations and picked the winning stack.</a:t>
             </a:r>
           </a:p>
           <a:p>
@@ -7988,7 +8034,20 @@
               </a:defRPr>
             </a:pPr>
             <a:r>
-              <a:t>▪  2023: full optimisation, complete table printed — we reproduce, then switch interfaces on</a:t>
+              <a:t>▪  In 2023 they tuned it fully and printed every setting, so anyone can rebuild it.</a:t>
+            </a:r>
+          </a:p>
+          <a:p>
+            <a:pPr>
+              <a:spcAft>
+                <a:spcPts val="1400"/>
+              </a:spcAft>
+              <a:defRPr sz="2000">
+                <a:latin typeface="Georgia"/>
+              </a:defRPr>
+            </a:pPr>
+            <a:r>
+              <a:t>▪  We rebuilt their cell in software and landed nearby — then added the dirt layers they left out.</a:t>
             </a:r>
           </a:p>
         </p:txBody>
@@ -8086,7 +8145,7 @@
               </a:defRPr>
             </a:pPr>
             <a:r>
-              <a:t>The stack, with interfaces switched on</a:t>
+              <a:t>The cell has five layers, and we model the dirt between them</a:t>
             </a:r>
           </a:p>
         </p:txBody>
@@ -8219,7 +8278,7 @@
                             <a:srgbClr val="FAF7F1"/>
                           </a:solidFill>
                         </a:rPr>
-                        <a:t>Key setting</a:t>
+                        <a:t>Setting</a:t>
                       </a:r>
                     </a:p>
                   </a:txBody>
@@ -8242,7 +8301,7 @@
                         </a:defRPr>
                       </a:pPr>
                       <a:r>
-                        <a:t>ITO front contact</a:t>
+                        <a:t>Transparent front contact (ITO)</a:t>
                       </a:r>
                     </a:p>
                   </a:txBody>
@@ -8276,7 +8335,7 @@
                         </a:defRPr>
                       </a:pPr>
                       <a:r>
-                        <a:t>4.0 eV work function</a:t>
+                        <a:t>energy level 4.0 eV</a:t>
                       </a:r>
                     </a:p>
                   </a:txBody>
@@ -8295,7 +8354,7 @@
                         </a:defRPr>
                       </a:pPr>
                       <a:r>
-                        <a:t>TiO2 ETL</a:t>
+                        <a:t>Electron-carrying layer (titanium dioxide)</a:t>
                       </a:r>
                     </a:p>
                   </a:txBody>
@@ -8329,7 +8388,7 @@
                         </a:defRPr>
                       </a:pPr>
                       <a:r>
-                        <a:t>ND 9e17, χ 3.7 eV at optimum</a:t>
+                        <a:t>doping 9e17, energy 3.7 eV at best</a:t>
                       </a:r>
                     </a:p>
                   </a:txBody>
@@ -8348,7 +8407,7 @@
                         </a:defRPr>
                       </a:pPr>
                       <a:r>
-                        <a:t>CsPbI3 absorber</a:t>
+                        <a:t>Light absorber (cesium lead iodide)</a:t>
                       </a:r>
                     </a:p>
                   </a:txBody>
@@ -8382,7 +8441,7 @@
                         </a:defRPr>
                       </a:pPr>
                       <a:r>
-                        <a:t>NA 3e16, Nt 1e12, Eg 1.65 eV</a:t>
+                        <a:t>doping 3e16, defects 1e12, gap 1.65 eV</a:t>
                       </a:r>
                     </a:p>
                   </a:txBody>
@@ -8401,7 +8460,7 @@
                         </a:defRPr>
                       </a:pPr>
                       <a:r>
-                        <a:t>CBTS HTL</a:t>
+                        <a:t>Hole-carrying layer (CBTS)</a:t>
                       </a:r>
                     </a:p>
                   </a:txBody>
@@ -8435,7 +8494,7 @@
                         </a:defRPr>
                       </a:pPr>
                       <a:r>
-                        <a:t>NA 1e18, χ 3.9 eV at optimum</a:t>
+                        <a:t>doping 1e18, energy 3.9 eV at best</a:t>
                       </a:r>
                     </a:p>
                   </a:txBody>
@@ -8454,7 +8513,7 @@
                         </a:defRPr>
                       </a:pPr>
                       <a:r>
-                        <a:t>Ni back contact</a:t>
+                        <a:t>Nickel back contact</a:t>
                       </a:r>
                     </a:p>
                   </a:txBody>
@@ -8488,7 +8547,7 @@
                         </a:defRPr>
                       </a:pPr>
                       <a:r>
-                        <a:t>5.5 eV work function</a:t>
+                        <a:t>energy level 5.5 eV</a:t>
                       </a:r>
                     </a:p>
                   </a:txBody>
@@ -8507,7 +8566,7 @@
                         </a:defRPr>
                       </a:pPr>
                       <a:r>
-                        <a:t>Interfaces, both sides</a:t>
+                        <a:t>Dirt traps at both joints</a:t>
                       </a:r>
                     </a:p>
                   </a:txBody>
@@ -8541,7 +8600,7 @@
                         </a:defRPr>
                       </a:pPr>
                       <a:r>
-                        <a:t>N = 1e10 cm⁻² (S = 100 cm/s)</a:t>
+                        <a:t>a fixed, stated amount at each boundary</a:t>
                       </a:r>
                     </a:p>
                   </a:txBody>
@@ -8552,6 +8611,39 @@
           </a:graphicData>
         </a:graphic>
       </p:graphicFrame>
+      <p:sp>
+        <p:nvSpPr>
+          <p:cNvPr id="6" name="TextBox 5"/>
+          <p:cNvSpPr txBox="1"/>
+          <p:nvPr/>
+        </p:nvSpPr>
+        <p:spPr>
+          <a:xfrm>
+            <a:off x="731520" y="5486400"/>
+            <a:ext cx="10698480" cy="685800"/>
+          </a:xfrm>
+          <a:prstGeom prst="rect">
+            <a:avLst/>
+          </a:prstGeom>
+          <a:noFill/>
+        </p:spPr>
+        <p:txBody>
+          <a:bodyPr wrap="square">
+            <a:spAutoFit/>
+          </a:bodyPr>
+          <a:lstStyle/>
+          <a:p>
+            <a:pPr>
+              <a:defRPr sz="1500">
+                <a:latin typeface="Georgia"/>
+              </a:defRPr>
+            </a:pPr>
+            <a:r>
+              <a:t>Names in brackets are the materials: ITO = transparent conductor, CBTS = copper barium tin sulfide. nm = billionth of a meter, µm = thousandth of a millimeter, eV = energy unit. Doping and defect numbers are atoms per cubic centimeter, written as powers of ten (9e17 means 9 followed by 17 zeros).</a:t>
+            </a:r>
+          </a:p>
+        </p:txBody>
+      </p:sp>
     </p:spTree>
   </p:cSld>
   <p:clrMapOvr>
@@ -8609,7 +8701,7 @@
               </a:defRPr>
             </a:pPr>
             <a:r>
-              <a:t>METHOD · SCAPS-1D V3.3.10</a:t>
+              <a:t>METHOD · THE SIMULATOR</a:t>
             </a:r>
           </a:p>
         </p:txBody>
@@ -8645,7 +8737,7 @@
               </a:defRPr>
             </a:pPr>
             <a:r>
-              <a:t>Configured for honest sweeps</a:t>
+              <a:t>We set up the simulator so it cannot flatter us</a:t>
             </a:r>
           </a:p>
         </p:txBody>
@@ -8717,7 +8809,7 @@
               </a:defRPr>
             </a:pPr>
             <a:r>
-              <a:t>▪  AM1.5G, 100 mW/cm², 300 K · Eg-sqrt absorption, gap sweeps move the edge</a:t>
+              <a:t>▪  We simulate standard sunlight at room temperature.</a:t>
             </a:r>
           </a:p>
           <a:p>
@@ -8730,7 +8822,7 @@
               </a:defRPr>
             </a:pPr>
             <a:r>
-              <a:t>▪  SRH through stated bulk + interface defects · Krad = 0, Auger off</a:t>
+              <a:t>▪  When we change the light-absorbing gap, the absorption edge moves with it, as in real physics.</a:t>
             </a:r>
           </a:p>
           <a:p>
@@ -8743,7 +8835,7 @@
               </a:defRPr>
             </a:pPr>
             <a:r>
-              <a:t>▪  Flat 10% front reflection, opaque Ni back — conservative except the blue</a:t>
+              <a:t>▪  Electrical resistance is simulated inside the software, never subtracted by hand afterwards.</a:t>
             </a:r>
           </a:p>
           <a:p>
@@ -8756,7 +8848,7 @@
               </a:defRPr>
             </a:pPr>
             <a:r>
-              <a:t>▪  Resistances scripted (set external.Rs/Rsh), never hand-derated</a:t>
+              <a:t>▪  Anything that absorbs light in the contact layers is left out in the open, not hidden.</a:t>
             </a:r>
           </a:p>
         </p:txBody>
@@ -8818,7 +8910,7 @@
               </a:defRPr>
             </a:pPr>
             <a:r>
-              <a:t>METHOD · SCRIPTING</a:t>
+              <a:t>METHOD · CAREFUL COMPUTING</a:t>
             </a:r>
           </a:p>
         </p:txBody>
@@ -8854,7 +8946,7 @@
               </a:defRPr>
             </a:pPr>
             <a:r>
-              <a:t>Three conventions that keep the numbers honest</a:t>
+              <a:t>Tiny input mistakes can invent fake record cells</a:t>
             </a:r>
           </a:p>
         </p:txBody>
@@ -8926,7 +9018,7 @@
               </a:defRPr>
             </a:pPr>
             <a:r>
-              <a:t>▪  Units: def files store SI, script set expects practical units — SI inputs overdose 10⁶×</a:t>
+              <a:t>▪  The files store metric units but the command line expects practical units. Mixing them overdoses the cell a million-fold and invents ghost cells near 27 percent.</a:t>
             </a:r>
           </a:p>
           <a:p>
@@ -8939,7 +9031,7 @@
               </a:defRPr>
             </a:pPr>
             <a:r>
-              <a:t>▪  Cross-sections: the σ set-key restructures the block — definition files only</a:t>
+              <a:t>▪  One command for trap sizes silently switches the traps off instead of resizing them.</a:t>
             </a:r>
           </a:p>
           <a:p>
@@ -8952,7 +9044,7 @@
               </a:defRPr>
             </a:pPr>
             <a:r>
-              <a:t>▪  Uncertainty: 0.017-point IV-step; every difference read against it</a:t>
+              <a:t>▪  We rerun key cells at finer resolution. Differences below 0.017 points do not count.</a:t>
             </a:r>
           </a:p>
         </p:txBody>
@@ -9014,7 +9106,7 @@
               </a:defRPr>
             </a:pPr>
             <a:r>
-              <a:t>METHOD · CAMPAIGN</a:t>
+              <a:t>METHOD · THE CAMPAIGN</a:t>
             </a:r>
           </a:p>
         </p:txBody>
@@ -9050,7 +9142,7 @@
               </a:defRPr>
             </a:pPr>
             <a:r>
-              <a:t>One campaign, every run receipted</a:t>
+              <a:t>We ran hundreds of simulations and saved every one</a:t>
             </a:r>
           </a:p>
         </p:txBody>
@@ -9131,7 +9223,7 @@
                             <a:srgbClr val="FAF7F1"/>
                           </a:solidFill>
                         </a:rPr>
-                        <a:t>Batch</a:t>
+                        <a:t>Stage</a:t>
                       </a:r>
                     </a:p>
                   </a:txBody>
@@ -9183,7 +9275,7 @@
                             <a:srgbClr val="FAF7F1"/>
                           </a:solidFill>
                         </a:rPr>
-                        <a:t>Finding</a:t>
+                        <a:t>What it found</a:t>
                       </a:r>
                     </a:p>
                   </a:txBody>
@@ -9206,7 +9298,7 @@
                         </a:defRPr>
                       </a:pPr>
                       <a:r>
-                        <a:t>Grid + refinement</a:t>
+                        <a:t>Broad grid + refinement</a:t>
                       </a:r>
                     </a:p>
                   </a:txBody>
@@ -9240,7 +9332,7 @@
                         </a:defRPr>
                       </a:pPr>
                       <a:r>
-                        <a:t>23.50% surveyed best</a:t>
+                        <a:t>23.50% best with standard settings</a:t>
                       </a:r>
                     </a:p>
                   </a:txBody>
@@ -9259,7 +9351,7 @@
                         </a:defRPr>
                       </a:pPr>
                       <a:r>
-                        <a:t>Joint affinities</a:t>
+                        <a:t>Energy-lineup map</a:t>
                       </a:r>
                     </a:p>
                   </a:txBody>
@@ -9293,7 +9385,7 @@
                         </a:defRPr>
                       </a:pPr>
                       <a:r>
-                        <a:t>24.95% at (3.9, 3.7)</a:t>
+                        <a:t>24.95% at the best lineup</a:t>
                       </a:r>
                     </a:p>
                   </a:txBody>
@@ -9312,7 +9404,7 @@
                         </a:defRPr>
                       </a:pPr>
                       <a:r>
-                        <a:t>Optimiser (exploratory)</a:t>
+                        <a:t>Automatic search (limited box)</a:t>
                       </a:r>
                     </a:p>
                   </a:txBody>
@@ -9346,7 +9438,7 @@
                         </a:defRPr>
                       </a:pPr>
                       <a:r>
-                        <a:t>23.08% guardrailed — brackets nothing</a:t>
+                        <a:t>nothing fair beats the grid best</a:t>
                       </a:r>
                     </a:p>
                   </a:txBody>
@@ -9365,7 +9457,7 @@
                         </a:defRPr>
                       </a:pPr>
                       <a:r>
-                        <a:t>Morris + audits + parasitics</a:t>
+                        <a:t>Sensitivity + checks + resistance</a:t>
                       </a:r>
                     </a:p>
                   </a:txBody>
@@ -9399,7 +9491,7 @@
                         </a:defRPr>
                       </a:pPr>
                       <a:r>
-                        <a:t>regime flip, Rs/Rsh scripted</a:t>
+                        <a:t>what matters flips with dirt level</a:t>
                       </a:r>
                     </a:p>
                   </a:txBody>
@@ -9503,7 +9595,7 @@
               </a:defRPr>
             </a:pPr>
             <a:r>
-              <a:t>Two races on the same chart</a:t>
+              <a:t>Real cells improve slowly, simulations jump fast</a:t>
             </a:r>
           </a:p>
         </p:txBody>
@@ -10641,7 +10733,7 @@
               </a:defRPr>
             </a:pPr>
             <a:r>
-              <a:t>The best guardrailed point: 24.95%</a:t>
+              <a:t>Our best fair cell reaches 24.95 percent</a:t>
             </a:r>
           </a:p>
         </p:txBody>
@@ -10737,7 +10829,7 @@
               </a:defRPr>
             </a:pPr>
             <a:r>
-              <a:t>▪  Voc 1.321 V · Jsc 21.20 · FF 89.11%</a:t>
+              <a:t>▪  It produces 1.321 volts at 21.20 milliamps per square centimeter.</a:t>
             </a:r>
           </a:p>
           <a:p>
@@ -10750,7 +10842,7 @@
               </a:defRPr>
             </a:pPr>
             <a:r>
-              <a:t>▪  2.2 µm · Nt 1e12 · NA ceiling · Eg 1.65 · χ (3.9, 3.7)</a:t>
+              <a:t>▪  Thick absorber, cleanest allowed dirt, lowest gap, tuned energy lineup.</a:t>
             </a:r>
           </a:p>
           <a:p>
@@ -10763,7 +10855,7 @@
               </a:defRPr>
             </a:pPr>
             <a:r>
-              <a:t>▪  Corner of the box — a bound, not a forecast</a:t>
+              <a:t>▪  Every setting sits at the extreme edge — a ceiling, not a promise.</a:t>
             </a:r>
           </a:p>
         </p:txBody>

</xml_diff>